<commit_message>
feat(slides): 講稿嵌入 pptx 每張備忘稿(speaker notes) + 口語潤稿
- build_slides.py 為 15 張各加上對應中文講稿到 notes 區
- 講稿順過成學生口吻、繁體語境通順；技術名詞/數字不變
- 同步更新 簡報講稿_zh.md
</commit_message>
<xml_diff>
--- a/Project/presentation/part2_HIV_vaccination.pptx
+++ b/Project/presentation/part2_HIV_vaccination.pptx
@@ -516,7 +516,529 @@
           <a:lstStyle/>
           <a:p>
             <a:r>
-              <a:t>Title. Part 2 of the term project: extend the sIC AIDS model with HIV vaccination and answer four questions — peak/decline, cost, optimum rate, vaccination vs condoms.</a:t>
+              <a:t>各位同學、老師好，我是李傳漢，學號 B11611027。今天要報告的是 term project 的 Part 2：在 sIC AIDS model 上面加入 HIV vaccination。</a:t>
+            </a:r>
+          </a:p>
+          <a:p/>
+          <a:p>
+            <a:r>
+              <a:t>這個 model 來自 Haefner 2005 課本第 15 章，它其實是 Imperial College model 的簡化版，我們叫它 sIC。那整個 Part 2 想回答的，是一個很實際的問題：打疫苗到底能不能讓 HIV 疫情往下走？它要花多少錢？最佳的接種率又是多少？還有，跟推廣保險套比起來，到底哪一個比較有效？</a:t>
+            </a:r>
+          </a:p>
+          <a:p/>
+          <a:p>
+            <a:r>
+              <a:t>接下來這十五分鐘，我會先把 model 講清楚，再一題一題回答這四個問題。</a:t>
+            </a:r>
+          </a:p>
+        </p:txBody>
+      </p:sp>
+      <p:sp>
+        <p:nvSpPr>
+          <p:cNvPr id="4" name="Slide Number Placeholder 3"/>
+          <p:cNvSpPr>
+            <a:spLocks noGrp="1"/>
+          </p:cNvSpPr>
+          <p:nvPr>
+            <p:ph type="sldNum" idx="5" sz="quarter"/>
+          </p:nvPr>
+        </p:nvSpPr>
+        <p:spPr/>
+      </p:sp>
+    </p:spTree>
+  </p:cSld>
+  <p:clrMapOvr>
+    <a:masterClrMapping/>
+  </p:clrMapOvr>
+</p:notes>
+</file>
+
+<file path=ppt/notesSlides/notesSlide10.xml><?xml version="1.0" encoding="utf-8"?>
+<p:notes xmlns:a="http://schemas.openxmlformats.org/drawingml/2006/main" xmlns:p="http://schemas.openxmlformats.org/presentationml/2006/main" xmlns:r="http://schemas.openxmlformats.org/officeDocument/2006/relationships">
+  <p:cSld>
+    <p:spTree>
+      <p:nvGrpSpPr>
+        <p:cNvPr id="1" name=""/>
+        <p:cNvGrpSpPr/>
+        <p:nvPr/>
+      </p:nvGrpSpPr>
+      <p:grpSpPr>
+        <a:xfrm>
+          <a:off x="0" y="0"/>
+          <a:ext cx="0" cy="0"/>
+          <a:chOff x="0" y="0"/>
+          <a:chExt cx="0" cy="0"/>
+        </a:xfrm>
+      </p:grpSpPr>
+      <p:sp>
+        <p:nvSpPr>
+          <p:cNvPr id="2" name="Slide Image Placeholder 1"/>
+          <p:cNvSpPr>
+            <a:spLocks noGrp="1"/>
+          </p:cNvSpPr>
+          <p:nvPr>
+            <p:ph type="sldImg" idx="2"/>
+          </p:nvPr>
+        </p:nvSpPr>
+        <p:spPr/>
+      </p:sp>
+      <p:sp>
+        <p:nvSpPr>
+          <p:cNvPr id="3" name="Notes Placeholder 2"/>
+          <p:cNvSpPr>
+            <a:spLocks noGrp="1"/>
+          </p:cNvSpPr>
+          <p:nvPr>
+            <p:ph type="body" idx="3" sz="quarter"/>
+          </p:nvPr>
+        </p:nvSpPr>
+        <p:spPr/>
+        <p:txBody>
+          <a:bodyPr/>
+          <a:lstStyle/>
+          <a:p>
+            <a:r>
+              <a:t>第三題：最佳接種率。先講 epidemiological threshold，也就是最小、能把 R_eff 壓到 1 以下的 ν_c。</a:t>
+            </a:r>
+          </a:p>
+          <a:p/>
+          <a:p>
+            <a:r>
+              <a:t>條件是穩態 protected fraction、也就是 ν 除以 (ν+l)，要大於等於 p_c。解出來的 closed form 是 ν_c 等於 l 乘上 p_c 除以 (1 − p_c)，大約 0.135。但這只是一個 lower bound，因為它忽略了兩件事：perinatal 那條疫苗擋不住的傳染路徑，還有 mortality 也會作用在 P 上面。</a:t>
+            </a:r>
+          </a:p>
+          <a:p/>
+          <a:p>
+            <a:r>
+              <a:t>所以我就直接用 invasion test 去量 —— 在打過疫苗的無病人口裡丟一點點感染，看早期成長率 r 在哪個 ν 穿過零、也就是 R_eff 等於 1。模擬出來的 ν_c 大約是 0.366，右邊這張圖就是那個 zero crossing。標準的 ν 等於 0.65 舒服地在它上面，所以確實能控制疫情。</a:t>
+            </a:r>
+          </a:p>
+          <a:p/>
+          <a:p>
+            <a:r>
+              <a:t>最後一點 caveat：如果錯誤地把 P 排除在分母外面，這個 threshold 會整個消失 —— 但那是分母選擇造成的 artifact，不是真實的結果。所以我特別把這個對照也畫進去。</a:t>
+            </a:r>
+          </a:p>
+        </p:txBody>
+      </p:sp>
+      <p:sp>
+        <p:nvSpPr>
+          <p:cNvPr id="4" name="Slide Number Placeholder 3"/>
+          <p:cNvSpPr>
+            <a:spLocks noGrp="1"/>
+          </p:cNvSpPr>
+          <p:nvPr>
+            <p:ph type="sldNum" idx="5" sz="quarter"/>
+          </p:nvPr>
+        </p:nvSpPr>
+        <p:spPr/>
+      </p:sp>
+    </p:spTree>
+  </p:cSld>
+  <p:clrMapOvr>
+    <a:masterClrMapping/>
+  </p:clrMapOvr>
+</p:notes>
+</file>
+
+<file path=ppt/notesSlides/notesSlide11.xml><?xml version="1.0" encoding="utf-8"?>
+<p:notes xmlns:a="http://schemas.openxmlformats.org/drawingml/2006/main" xmlns:p="http://schemas.openxmlformats.org/presentationml/2006/main" xmlns:r="http://schemas.openxmlformats.org/officeDocument/2006/relationships">
+  <p:cSld>
+    <p:spTree>
+      <p:nvGrpSpPr>
+        <p:cNvPr id="1" name=""/>
+        <p:cNvGrpSpPr/>
+        <p:nvPr/>
+      </p:nvGrpSpPr>
+      <p:grpSpPr>
+        <a:xfrm>
+          <a:off x="0" y="0"/>
+          <a:ext cx="0" cy="0"/>
+          <a:chOff x="0" y="0"/>
+          <a:chExt cx="0" cy="0"/>
+        </a:xfrm>
+      </p:grpSpPr>
+      <p:sp>
+        <p:nvSpPr>
+          <p:cNvPr id="2" name="Slide Image Placeholder 1"/>
+          <p:cNvSpPr>
+            <a:spLocks noGrp="1"/>
+          </p:cNvSpPr>
+          <p:nvPr>
+            <p:ph type="sldImg" idx="2"/>
+          </p:nvPr>
+        </p:nvSpPr>
+        <p:spPr/>
+      </p:sp>
+      <p:sp>
+        <p:nvSpPr>
+          <p:cNvPr id="3" name="Notes Placeholder 2"/>
+          <p:cNvSpPr>
+            <a:spLocks noGrp="1"/>
+          </p:cNvSpPr>
+          <p:nvPr>
+            <p:ph type="body" idx="3" sz="quarter"/>
+          </p:nvPr>
+        </p:nvSpPr>
+        <p:spPr/>
+        <p:txBody>
+          <a:bodyPr/>
+          <a:lstStyle/>
+          <a:p>
+            <a:r>
+              <a:t>這張一樣是第三題，但「最佳」其實有兩個合理的意思，我兩個都報。前一張是 epidemiological 的；這一張是 cost-effective 的。</a:t>
+            </a:r>
+          </a:p>
+          <a:p/>
+          <a:p>
+            <a:r>
+              <a:t>關鍵在於：avoided infections 在超過 ν_c 之後會「飽和」。在 ν_c 以下，每多一點 ν 都能多避免很多感染；可是一旦超過 ν_c，大約 13400 個可避免的感染幾乎都已經被避免掉了，再加大接種，其實只是在重複幫衰退的人補打，效益很低。</a:t>
+            </a:r>
+          </a:p>
+          <a:p/>
+          <a:p>
+            <a:r>
+              <a:t>所以這裡有一個 diminishing-returns 的膝點 —— 能抓到 99% 最大避免量的最小 ν，大約在 0.175，那邊的邊際成本大約是每個感染 122 美元。標準的 ν 等於 0.65 雖然確實能控制疫情，但相對於這個 cost-effective 膝點，其實是「打多了」。這就是為什麼 epidemiological 最佳跟 cost-effective 最佳，答案會不一樣。</a:t>
+            </a:r>
+          </a:p>
+        </p:txBody>
+      </p:sp>
+      <p:sp>
+        <p:nvSpPr>
+          <p:cNvPr id="4" name="Slide Number Placeholder 3"/>
+          <p:cNvSpPr>
+            <a:spLocks noGrp="1"/>
+          </p:cNvSpPr>
+          <p:nvPr>
+            <p:ph type="sldNum" idx="5" sz="quarter"/>
+          </p:nvPr>
+        </p:nvSpPr>
+        <p:spPr/>
+      </p:sp>
+    </p:spTree>
+  </p:cSld>
+  <p:clrMapOvr>
+    <a:masterClrMapping/>
+  </p:clrMapOvr>
+</p:notes>
+</file>
+
+<file path=ppt/notesSlides/notesSlide12.xml><?xml version="1.0" encoding="utf-8"?>
+<p:notes xmlns:a="http://schemas.openxmlformats.org/drawingml/2006/main" xmlns:p="http://schemas.openxmlformats.org/presentationml/2006/main" xmlns:r="http://schemas.openxmlformats.org/officeDocument/2006/relationships">
+  <p:cSld>
+    <p:spTree>
+      <p:nvGrpSpPr>
+        <p:cNvPr id="1" name=""/>
+        <p:cNvGrpSpPr/>
+        <p:nvPr/>
+      </p:nvGrpSpPr>
+      <p:grpSpPr>
+        <a:xfrm>
+          <a:off x="0" y="0"/>
+          <a:ext cx="0" cy="0"/>
+          <a:chOff x="0" y="0"/>
+          <a:chExt cx="0" cy="0"/>
+        </a:xfrm>
+      </p:grpSpPr>
+      <p:sp>
+        <p:nvSpPr>
+          <p:cNvPr id="2" name="Slide Image Placeholder 1"/>
+          <p:cNvSpPr>
+            <a:spLocks noGrp="1"/>
+          </p:cNvSpPr>
+          <p:nvPr>
+            <p:ph type="sldImg" idx="2"/>
+          </p:nvPr>
+        </p:nvSpPr>
+        <p:spPr/>
+      </p:sp>
+      <p:sp>
+        <p:nvSpPr>
+          <p:cNvPr id="3" name="Notes Placeholder 2"/>
+          <p:cNvSpPr>
+            <a:spLocks noGrp="1"/>
+          </p:cNvSpPr>
+          <p:nvPr>
+            <p:ph type="body" idx="3" sz="quarter"/>
+          </p:nvPr>
+        </p:nvSpPr>
+        <p:spPr/>
+        <p:txBody>
+          <a:bodyPr/>
+          <a:lstStyle/>
+          <a:p>
+            <a:r>
+              <a:t>最後一題：疫苗跟保險套，哪一個比較會控制疫情？</a:t>
+            </a:r>
+          </a:p>
+          <a:p/>
+          <a:p>
+            <a:r>
+              <a:t>其實兩個都能控制。疫苗把 R_eff 壓到 0.31，嚴格小於 1；保險套把 R₀ 降到 1.17，還是稍微在 1 上面 —— 也就是說，減半 β 在這個 R₀ 還差一點點才跨過 threshold，但疫情已經慢到在時間範圍內等於被控制住了。</a:t>
+            </a:r>
+          </a:p>
+          <a:p/>
+          <a:p>
+            <a:r>
+              <a:t>在 avoided infections 上面兩者幾乎一樣：總共 31235 個感染，疫苗避免 31224、保險套避免 30857。疫苗只是稍微領先，因為它讓 R_eff 嚴格小於 1，殘留 11 個感染，而保險套殘留 378 個。</a:t>
+            </a:r>
+          </a:p>
+          <a:p/>
+          <a:p>
+            <a:r>
+              <a:t>那真正差很多的是成本基礎，這也是為什麼我不願意硬選一個贏家。疫苗有明確的 34 萬 8618 美元，而且因為 waning ceiling，要無限期地幫衰退的人補打。保險套這邊是被當成永久把 R₀ 砍半、而且沒有定價 —— 但「沒定價」不等於「免費」，真實的行為改變計畫也有它自己的預算，只是專案沒給。再加上 near-threshold 的敏感性，兩邊的結論都對 R₀ 很敏感。所以老實的講法是：在疫情結果上是接近平手，疫苗因為嚴格跨過 threshold 稍微領先，但以目前的定價方式，兩者沒辦法直接比成本。</a:t>
+            </a:r>
+          </a:p>
+        </p:txBody>
+      </p:sp>
+      <p:sp>
+        <p:nvSpPr>
+          <p:cNvPr id="4" name="Slide Number Placeholder 3"/>
+          <p:cNvSpPr>
+            <a:spLocks noGrp="1"/>
+          </p:cNvSpPr>
+          <p:nvPr>
+            <p:ph type="sldNum" idx="5" sz="quarter"/>
+          </p:nvPr>
+        </p:nvSpPr>
+        <p:spPr/>
+      </p:sp>
+    </p:spTree>
+  </p:cSld>
+  <p:clrMapOvr>
+    <a:masterClrMapping/>
+  </p:clrMapOvr>
+</p:notes>
+</file>
+
+<file path=ppt/notesSlides/notesSlide13.xml><?xml version="1.0" encoding="utf-8"?>
+<p:notes xmlns:a="http://schemas.openxmlformats.org/drawingml/2006/main" xmlns:p="http://schemas.openxmlformats.org/presentationml/2006/main" xmlns:r="http://schemas.openxmlformats.org/officeDocument/2006/relationships">
+  <p:cSld>
+    <p:spTree>
+      <p:nvGrpSpPr>
+        <p:cNvPr id="1" name=""/>
+        <p:cNvGrpSpPr/>
+        <p:nvPr/>
+      </p:nvGrpSpPr>
+      <p:grpSpPr>
+        <a:xfrm>
+          <a:off x="0" y="0"/>
+          <a:ext cx="0" cy="0"/>
+          <a:chOff x="0" y="0"/>
+          <a:chExt cx="0" cy="0"/>
+        </a:xfrm>
+      </p:grpSpPr>
+      <p:sp>
+        <p:nvSpPr>
+          <p:cNvPr id="2" name="Slide Image Placeholder 1"/>
+          <p:cNvSpPr>
+            <a:spLocks noGrp="1"/>
+          </p:cNvSpPr>
+          <p:nvPr>
+            <p:ph type="sldImg" idx="2"/>
+          </p:nvPr>
+        </p:nvSpPr>
+        <p:spPr/>
+      </p:sp>
+      <p:sp>
+        <p:nvSpPr>
+          <p:cNvPr id="3" name="Notes Placeholder 2"/>
+          <p:cNvSpPr>
+            <a:spLocks noGrp="1"/>
+          </p:cNvSpPr>
+          <p:nvPr>
+            <p:ph type="body" idx="3" sz="quarter"/>
+          </p:nvPr>
+        </p:nvSpPr>
+        <p:spPr/>
+        <p:txBody>
+          <a:bodyPr/>
+          <a:lstStyle/>
+          <a:p>
+            <a:r>
+              <a:t>把結論收一下。</a:t>
+            </a:r>
+          </a:p>
+          <a:p/>
+          <a:p>
+            <a:r>
+              <a:t>第一，ν 等於 0.65 的疫苗能控制疫情：R_eff 大約 0.31、小於 1，疫情根本不會 ignite，prevalence 維持在接近零，而不是 baseline 那個大約 0.41 的 endemic plateau。</a:t>
+            </a:r>
+          </a:p>
+          <a:p/>
+          <a:p>
+            <a:r>
+              <a:t>第二，它具有成本效益：30 年的時候，每避免一個感染大約 102 美元，落在已發表的 Garnett/Stover 範圍內。</a:t>
+            </a:r>
+          </a:p>
+          <a:p/>
+          <a:p>
+            <a:r>
+              <a:t>第三，存在一個有限的最佳值：threshold ν_c 大約 0.37，而 cost-effective 膝點大約 0.18，所以標準的 0.65 其實打得稍微多了一點。</a:t>
+            </a:r>
+          </a:p>
+          <a:p/>
+          <a:p>
+            <a:r>
+              <a:t>第四，疫苗跟保險套在結果上差不多，疫苗嚴格跨過 threshold，但以目前的定價方式，兩者不能直接比成本。</a:t>
+            </a:r>
+          </a:p>
+        </p:txBody>
+      </p:sp>
+      <p:sp>
+        <p:nvSpPr>
+          <p:cNvPr id="4" name="Slide Number Placeholder 3"/>
+          <p:cNvSpPr>
+            <a:spLocks noGrp="1"/>
+          </p:cNvSpPr>
+          <p:nvPr>
+            <p:ph type="sldNum" idx="5" sz="quarter"/>
+          </p:nvPr>
+        </p:nvSpPr>
+        <p:spPr/>
+      </p:sp>
+    </p:spTree>
+  </p:cSld>
+  <p:clrMapOvr>
+    <a:masterClrMapping/>
+  </p:clrMapOvr>
+</p:notes>
+</file>
+
+<file path=ppt/notesSlides/notesSlide14.xml><?xml version="1.0" encoding="utf-8"?>
+<p:notes xmlns:a="http://schemas.openxmlformats.org/drawingml/2006/main" xmlns:p="http://schemas.openxmlformats.org/presentationml/2006/main" xmlns:r="http://schemas.openxmlformats.org/officeDocument/2006/relationships">
+  <p:cSld>
+    <p:spTree>
+      <p:nvGrpSpPr>
+        <p:cNvPr id="1" name=""/>
+        <p:cNvGrpSpPr/>
+        <p:nvPr/>
+      </p:nvGrpSpPr>
+      <p:grpSpPr>
+        <a:xfrm>
+          <a:off x="0" y="0"/>
+          <a:ext cx="0" cy="0"/>
+          <a:chOff x="0" y="0"/>
+          <a:chExt cx="0" cy="0"/>
+        </a:xfrm>
+      </p:grpSpPr>
+      <p:sp>
+        <p:nvSpPr>
+          <p:cNvPr id="2" name="Slide Image Placeholder 1"/>
+          <p:cNvSpPr>
+            <a:spLocks noGrp="1"/>
+          </p:cNvSpPr>
+          <p:nvPr>
+            <p:ph type="sldImg" idx="2"/>
+          </p:nvPr>
+        </p:nvSpPr>
+        <p:spPr/>
+      </p:sp>
+      <p:sp>
+        <p:nvSpPr>
+          <p:cNvPr id="3" name="Notes Placeholder 2"/>
+          <p:cNvSpPr>
+            <a:spLocks noGrp="1"/>
+          </p:cNvSpPr>
+          <p:nvPr>
+            <p:ph type="body" idx="3" sz="quarter"/>
+          </p:nvPr>
+        </p:nvSpPr>
+        <p:spPr/>
+        <p:txBody>
+          <a:bodyPr/>
+          <a:lstStyle/>
+          <a:p>
+            <a:r>
+              <a:t>最後我想老實交代一下，這些結論是建立在哪些假設上面。</a:t>
+            </a:r>
+          </a:p>
+          <a:p/>
+          <a:p>
+            <a:r>
+              <a:t>第一，γ 從 1.16 改成 0.1，是為了讓疫情能 ignite 才不得不做的，它會移動絕對水準。第二，near-threshold 敏感性：保險套讓 R₀ 停在 1.17，所以小小的校準改變就會讓 endemic level 變很多。第三，partner-pool 慣例 —— 把 P 放進分母 —— 是 load-bearing 的，它正是疫苗 herd-immunity 效果的來源。第四，人口很小、是合成的，N₀ 只有 8005，所以金額是示意性的，要用每個感染的成本來看。第五，我只測了單一操作點 ν 等於 0.65、l 等於 0.1，而且把 ν 當成常數速率，這是對 Garnett/Stover coverage 情境的簡化。</a:t>
+            </a:r>
+          </a:p>
+          <a:p/>
+          <a:p>
+            <a:r>
+              <a:t>換句話說，所有結論都是有條件的，而我選擇把這些條件講清楚，而不是把它藏起來。</a:t>
+            </a:r>
+          </a:p>
+        </p:txBody>
+      </p:sp>
+      <p:sp>
+        <p:nvSpPr>
+          <p:cNvPr id="4" name="Slide Number Placeholder 3"/>
+          <p:cNvSpPr>
+            <a:spLocks noGrp="1"/>
+          </p:cNvSpPr>
+          <p:nvPr>
+            <p:ph type="sldNum" idx="5" sz="quarter"/>
+          </p:nvPr>
+        </p:nvSpPr>
+        <p:spPr/>
+      </p:sp>
+    </p:spTree>
+  </p:cSld>
+  <p:clrMapOvr>
+    <a:masterClrMapping/>
+  </p:clrMapOvr>
+</p:notes>
+</file>
+
+<file path=ppt/notesSlides/notesSlide15.xml><?xml version="1.0" encoding="utf-8"?>
+<p:notes xmlns:a="http://schemas.openxmlformats.org/drawingml/2006/main" xmlns:p="http://schemas.openxmlformats.org/presentationml/2006/main" xmlns:r="http://schemas.openxmlformats.org/officeDocument/2006/relationships">
+  <p:cSld>
+    <p:spTree>
+      <p:nvGrpSpPr>
+        <p:cNvPr id="1" name=""/>
+        <p:cNvGrpSpPr/>
+        <p:nvPr/>
+      </p:nvGrpSpPr>
+      <p:grpSpPr>
+        <a:xfrm>
+          <a:off x="0" y="0"/>
+          <a:ext cx="0" cy="0"/>
+          <a:chOff x="0" y="0"/>
+          <a:chExt cx="0" cy="0"/>
+        </a:xfrm>
+      </p:grpSpPr>
+      <p:sp>
+        <p:nvSpPr>
+          <p:cNvPr id="2" name="Slide Image Placeholder 1"/>
+          <p:cNvSpPr>
+            <a:spLocks noGrp="1"/>
+          </p:cNvSpPr>
+          <p:nvPr>
+            <p:ph type="sldImg" idx="2"/>
+          </p:nvPr>
+        </p:nvSpPr>
+        <p:spPr/>
+      </p:sp>
+      <p:sp>
+        <p:nvSpPr>
+          <p:cNvPr id="3" name="Notes Placeholder 2"/>
+          <p:cNvSpPr>
+            <a:spLocks noGrp="1"/>
+          </p:cNvSpPr>
+          <p:nvPr>
+            <p:ph type="body" idx="3" sz="quarter"/>
+          </p:nvPr>
+        </p:nvSpPr>
+        <p:spPr/>
+        <p:txBody>
+          <a:bodyPr/>
+          <a:lstStyle/>
+          <a:p>
+            <a:r>
+              <a:t>以上就是我的報告，謝謝大家，也歡迎提問。</a:t>
+            </a:r>
+          </a:p>
+          <a:p/>
+          <a:p>
+            <a:r>
+              <a:t>如果需要的話，下面這幾個常數可以幫我快速回答問題：R₀ 是 2.35、p_c 是 0.574、waning ceiling 0.87、ν_c 大約 0.37、ν 等於 0.65 的時候 R_eff 是 0.31。</a:t>
             </a:r>
           </a:p>
         </p:txBody>
@@ -586,7 +1108,19 @@
           <a:lstStyle/>
           <a:p>
             <a:r>
-              <a:t>Motivation: four questions — (a) peak/decline, (b) cost, (c) optimum rate, (d) vaccination vs condoms — tested against one common baseline. HIV is S-&gt;I-&gt;AIDS with births, so it persists endemically.</a:t>
+              <a:t>先講一下為什麼要用 model。HIV 是一個透過性行為傳播、而且會拖很久的疫情，它的變化是用「幾十年」當單位在跑的。這種時間尺度，其實光靠直覺很不可靠 —— 你很難憑感覺去判斷一個介入措施在二、三十年後會累積出什麼效果。</a:t>
+            </a:r>
+          </a:p>
+          <a:p/>
+          <a:p>
+            <a:r>
+              <a:t>所以我們用 compartment model，把原本很模糊的政策問題，變成可以量化、而且可以在同一個 baseline 上面公平比較的問題。</a:t>
+            </a:r>
+          </a:p>
+          <a:p/>
+          <a:p>
+            <a:r>
+              <a:t>那 Part 2 具體就是四個問題：(a) 打疫苗會不會讓疫情先到高峰再下降；(b) 每避免一個感染要花多少錢；(c) 最佳接種率是多少；還有 (d) 疫苗跟保險套比起來怎麼樣。這四題我都會回到同一個 baseline 來比。</a:t>
             </a:r>
           </a:p>
         </p:txBody>
@@ -656,7 +1190,19 @@
           <a:lstStyle/>
           <a:p>
             <a:r>
-              <a:t>12 compartments: S/I/AIDS disease classes crossed with sex (f/m) and two age groups (0-15, 16+). Force of infection is frequency-dependent, I/(S+I); AIDS class excluded from the partner pool.</a:t>
+              <a:t>那先來看 model 本身。sIC 把人口切成 12 個 compartment：先是三個疾病狀態 —— S 是 susceptible 易感者、I 是感染了 HIV 但還沒發病、A 是臨床 AIDS；這三個再乘上性別，女 f、男 m，再乘上兩個年齡層 —— age 1 是 0 到 15 歲、還沒有性行為，age 2 是 16 歲以上、有性行為。所以三乘二乘二，剛好 12 格，就是右邊這張表。</a:t>
+            </a:r>
+          </a:p>
+          <a:p/>
+          <a:p>
+            <a:r>
+              <a:t>這裡有幾個重點：第一，只有 age 2 的人會傳染。第二，這是一個 Forrester 式的 flow model，裡面有出生、有 ageing 用 ξ、有 I 進展到 A 用 γ、還有 AIDS 死亡 α。</a:t>
+            </a:r>
+          </a:p>
+          <a:p/>
+          <a:p>
+            <a:r>
+              <a:t>那最關鍵的是 force of infection。HIV 是 frequency-dependent，也就是說，重要的不是感染者的「絕對數量」，而是在你可能的性伴侶裡面，有多大「比例」是感染者 —— 所以是 I 除以 (S+I)。注意 A 不在分母裡面，因為臨床 AIDS 的人被假設不再有性行為。這個細節等一下會變得很重要。</a:t>
             </a:r>
           </a:p>
         </p:txBody>
@@ -726,7 +1272,13 @@
           <a:lstStyle/>
           <a:p>
             <a:r>
-              <a:t>Parameters from Table 15.2. Transmission asymmetric: βmf 0.20 vs βfm 0.075, so female prevalence exceeds male. Births refill susceptibles, giving an endemic plateau rather than burnout.</a:t>
+              <a:t>這張是 Table 15.2 的關鍵參數。我想特別點出一件事：傳染機率是不對稱的。男傳女 β 是 0.20，女傳男只有 0.075，差不多 2.7 倍。這是異性戀 HIV 一個很標準的生物特性，也正是為什麼在 baseline 裡，女性的 equilibrium prevalence 會比男性高。</a:t>
+            </a:r>
+          </a:p>
+          <a:p/>
+          <a:p>
+            <a:r>
+              <a:t>人口結構這邊也有幾個要記得的點：出生只由 age-2 的女性產生，而且發展中國家生育率高，所以人口在前期是會成長的。另外還有一個 perinatal route，ϑ 等於 0.35，意思是感染的母親有機會生出已經感染的新生兒 —— 這條傳染路徑，疫苗是擋不住的，等一下講 threshold 的時候會再提到。初始人口 N(0) 是 8005 人。</a:t>
             </a:r>
           </a:p>
         </p:txBody>
@@ -796,7 +1348,19 @@
           <a:lstStyle/>
           <a:p>
             <a:r>
-              <a:t>Takeaways: vaccination at ν=0.65 drives R_eff&lt;1 and the epidemic declines; it is cost-effective (~$102/infection averted); comparable to condoms; conclusions hold above the herd-immunity threshold νc≈0.37.</a:t>
+              <a:t>接下來這兩張，是我為了讓 model 真的跑出課本描述的行為，必須做的兩個判斷。我選擇老實講出來，因為它們會影響結果。</a:t>
+            </a:r>
+          </a:p>
+          <a:p/>
+          <a:p>
+            <a:r>
+              <a:t>第一個是進展率 γ。R₀ 的公式是 c 乘上根號 (β_mf × β_fm)，再除以 (μ+γ)。課本 Table 15.2 給的 γ 是 1.16，但這代表從感染到發病平均只有 0.85 年、不到一年，這跟課本自己講的「1 到 10 年」是矛盾的。更糟的是，把 1.16 代進去，R₀ 大概只有 0.24，小於 1，疫情根本點不起來 —— 我實際去模擬，seed 進去的感染就直接消失了。這跟 Fig 15.5「HIV 持續存在」完全相反。</a:t>
+            </a:r>
+          </a:p>
+          <a:p/>
+          <a:p>
+            <a:r>
+              <a:t>所以我改用比較有生物根據的 γ 等於 0.1，平均感染期大概 8.1 年，落在課本說的範圍內，這時候 R₀ 大概是 2.35，大於 1，疫情就會 invade，跟課本的圖一致。對應的 herd-immunity threshold，也就是 p_c，是 1 減 1 除以 R₀，大約 0.574。右邊這張圖就是修正之後的 baseline：HIV 持續存在，而且女性 prevalence 高於男性。</a:t>
             </a:r>
           </a:p>
         </p:txBody>
@@ -866,7 +1430,19 @@
           <a:lstStyle/>
           <a:p>
             <a:r>
-              <a:t>Limitations: γ recalibrated; near-threshold sensitivity; small synthetic population (use $/infection averted); single operating point; herd immunity depends on protected people staying in the partner pool.</a:t>
+              <a:t>第二個判斷是 seed 要放哪裡。Table 15.2 是放 5 個 AIDS 男性，A_{m2} 等於 5。但前面講過，A 不在 force of infection 裡面，所以這 5 個人根本傳不出去 —— 他們只會進展、死亡，疫情永遠不會開始，我模擬出來 incidence 剛好就是零。那最小的修正，就是改成 seed 5 個 infectious 男性，I_{m2} 等於 5。</a:t>
+            </a:r>
+          </a:p>
+          <a:p/>
+          <a:p>
+            <a:r>
+              <a:t>做了這兩個修正之後，baseline 就重現了 Fig 15.5a：女性 prevalence 大約 0.77，男性大約 0.61，順序對、而且 HIV 持續存在。</a:t>
+            </a:r>
+          </a:p>
+          <a:p/>
+          <a:p>
+            <a:r>
+              <a:t>右邊是 condom scenario，做法跟課本一樣，把兩個 β 都減半。因為 R₀ 正比於根號 β，減半剛好讓 R₀ 變成 1.17，只比 threshold 高一點點，所以 prevalence 會崩掉。這就是 near-threshold 的敏感性 —— 在 1 附近，小小的調整就會讓結果差很多。我選擇把這個 divergence 講出來，而不是去硬調參數。</a:t>
             </a:r>
           </a:p>
         </p:txBody>
@@ -936,7 +1512,189 @@
           <a:lstStyle/>
           <a:p>
             <a:r>
-              <a:t>Closing. Recap: R0≈2.35 → with ν=0.65, R_eff≈0.31&lt;1.</a:t>
+              <a:t>現在來加上疫苗。我加了兩個 protected compartment，P_{f2} 跟 P_{m2}，只在 age 2。易感者會以 per-capita 速率 ν 被接種進 P，而保護力會以速率 l 衰退、回到 S，所以它是一個 S 到 P 再回到 S 的循環。</a:t>
+            </a:r>
+          </a:p>
+          <a:p/>
+          <a:p>
+            <a:r>
+              <a:t>疫苗型態我用的是 take，也就是 all-or-nothing：在 P 裡面的人完全受保護，force of infection 不會作用在他們身上。專案的標準值是 ν 等於 0.65、l 等於 0.1。</a:t>
+            </a:r>
+          </a:p>
+          <a:p/>
+          <a:p>
+            <a:r>
+              <a:t>那這裡有一個解析上的上限，叫 waning ceiling：P 佔 (S+P) 的比例，最多到 ν 除以 (ν+l)，也就是 0.65 除以 0.75，大約 0.87。所以就算你一直打，任何時刻最多也只有大約 87% 的人受保護。成本我用一個 accumulator 去累計，dV/dt 等於 ν 乘上兩性 age-2 的易感者，每劑算 10 美元。</a:t>
+            </a:r>
+          </a:p>
+          <a:p/>
+          <a:p>
+            <a:r>
+              <a:t>那最關鍵的一個慣例在最後一點：受保護的人雖然沒被感染，可是他們還是有性行為、還是合法的性伴侶，只是跟他們發生關係不會傳染。所以他們要留在分母裡面，force of infection 就變成 I 除以 (S+I+P)。把易感者移進 P 會稀釋掉感染者的比例 —— 其實這個稀釋，正是 herd immunity 的機制。</a:t>
+            </a:r>
+          </a:p>
+        </p:txBody>
+      </p:sp>
+      <p:sp>
+        <p:nvSpPr>
+          <p:cNvPr id="4" name="Slide Number Placeholder 3"/>
+          <p:cNvSpPr>
+            <a:spLocks noGrp="1"/>
+          </p:cNvSpPr>
+          <p:nvPr>
+            <p:ph type="sldNum" idx="5" sz="quarter"/>
+          </p:nvPr>
+        </p:nvSpPr>
+        <p:spPr/>
+      </p:sp>
+    </p:spTree>
+  </p:cSld>
+  <p:clrMapOvr>
+    <a:masterClrMapping/>
+  </p:clrMapOvr>
+</p:notes>
+</file>
+
+<file path=ppt/notesSlides/notesSlide8.xml><?xml version="1.0" encoding="utf-8"?>
+<p:notes xmlns:a="http://schemas.openxmlformats.org/drawingml/2006/main" xmlns:p="http://schemas.openxmlformats.org/presentationml/2006/main" xmlns:r="http://schemas.openxmlformats.org/officeDocument/2006/relationships">
+  <p:cSld>
+    <p:spTree>
+      <p:nvGrpSpPr>
+        <p:cNvPr id="1" name=""/>
+        <p:cNvGrpSpPr/>
+        <p:nvPr/>
+      </p:nvGrpSpPr>
+      <p:grpSpPr>
+        <a:xfrm>
+          <a:off x="0" y="0"/>
+          <a:ext cx="0" cy="0"/>
+          <a:chOff x="0" y="0"/>
+          <a:chExt cx="0" cy="0"/>
+        </a:xfrm>
+      </p:grpSpPr>
+      <p:sp>
+        <p:nvSpPr>
+          <p:cNvPr id="2" name="Slide Image Placeholder 1"/>
+          <p:cNvSpPr>
+            <a:spLocks noGrp="1"/>
+          </p:cNvSpPr>
+          <p:nvPr>
+            <p:ph type="sldImg" idx="2"/>
+          </p:nvPr>
+        </p:nvSpPr>
+        <p:spPr/>
+      </p:sp>
+      <p:sp>
+        <p:nvSpPr>
+          <p:cNvPr id="3" name="Notes Placeholder 2"/>
+          <p:cNvSpPr>
+            <a:spLocks noGrp="1"/>
+          </p:cNvSpPr>
+          <p:nvPr>
+            <p:ph type="body" idx="3" sz="quarter"/>
+          </p:nvPr>
+        </p:nvSpPr>
+        <p:spPr/>
+        <p:txBody>
+          <a:bodyPr/>
+          <a:lstStyle/>
+          <a:p>
+            <a:r>
+              <a:t>那第一題：打疫苗會不會讓疫情先到高峰再下降？答案其實比「高峰再下降」還要更強。</a:t>
+            </a:r>
+          </a:p>
+          <a:p/>
+          <a:p>
+            <a:r>
+              <a:t>因為可達到的 protected fraction 0.87 高過 herd-immunity threshold 0.574，所以 R_eff 大概等於 R₀ 乘上 (1 − 0.867)，大約 0.31，小於 1。也就是說，疫情根本沒辦法 ignite。</a:t>
+            </a:r>
+          </a:p>
+          <a:p/>
+          <a:p>
+            <a:r>
+              <a:t>你看左邊這張 incidence 圖：打疫苗那一條，最高點就在 t 等於 0，那其實只是一開始 5 個 seed 男性傳給少數幾個人，之後就單調往下掉到接近零。對比 baseline，它衝到大約每年 791 個新感染、在第 48 年左右到高峰，而且維持得很高。那下降不是瞬間發生的，因為原本的 I 跟 A 還要花八到十年才會進展、死亡，但因為 R_eff 小於 1，沒有新的傳染去補充，病毒就被清掉了。同時 protected fraction 飽和在大約 0.85，剛好在 0.867 這個上限下面一點，符合 take-with-waning 的穩態。</a:t>
+            </a:r>
+          </a:p>
+        </p:txBody>
+      </p:sp>
+      <p:sp>
+        <p:nvSpPr>
+          <p:cNvPr id="4" name="Slide Number Placeholder 3"/>
+          <p:cNvSpPr>
+            <a:spLocks noGrp="1"/>
+          </p:cNvSpPr>
+          <p:nvPr>
+            <p:ph type="sldNum" idx="5" sz="quarter"/>
+          </p:nvPr>
+        </p:nvSpPr>
+        <p:spPr/>
+      </p:sp>
+    </p:spTree>
+  </p:cSld>
+  <p:clrMapOvr>
+    <a:masterClrMapping/>
+  </p:clrMapOvr>
+</p:notes>
+</file>
+
+<file path=ppt/notesSlides/notesSlide9.xml><?xml version="1.0" encoding="utf-8"?>
+<p:notes xmlns:a="http://schemas.openxmlformats.org/drawingml/2006/main" xmlns:p="http://schemas.openxmlformats.org/presentationml/2006/main" xmlns:r="http://schemas.openxmlformats.org/officeDocument/2006/relationships">
+  <p:cSld>
+    <p:spTree>
+      <p:nvGrpSpPr>
+        <p:cNvPr id="1" name=""/>
+        <p:cNvGrpSpPr/>
+        <p:nvPr/>
+      </p:nvGrpSpPr>
+      <p:grpSpPr>
+        <a:xfrm>
+          <a:off x="0" y="0"/>
+          <a:ext cx="0" cy="0"/>
+          <a:chOff x="0" y="0"/>
+          <a:chExt cx="0" cy="0"/>
+        </a:xfrm>
+      </p:grpSpPr>
+      <p:sp>
+        <p:nvSpPr>
+          <p:cNvPr id="2" name="Slide Image Placeholder 1"/>
+          <p:cNvSpPr>
+            <a:spLocks noGrp="1"/>
+          </p:cNvSpPr>
+          <p:nvPr>
+            <p:ph type="sldImg" idx="2"/>
+          </p:nvPr>
+        </p:nvSpPr>
+        <p:spPr/>
+      </p:sp>
+      <p:sp>
+        <p:nvSpPr>
+          <p:cNvPr id="3" name="Notes Placeholder 2"/>
+          <p:cNvSpPr>
+            <a:spLocks noGrp="1"/>
+          </p:cNvSpPr>
+          <p:nvPr>
+            <p:ph type="body" idx="3" sz="quarter"/>
+          </p:nvPr>
+        </p:nvSpPr>
+        <p:spPr/>
+        <p:txBody>
+          <a:bodyPr/>
+          <a:lstStyle/>
+          <a:p>
+            <a:r>
+              <a:t>第二題是成本。用剛剛那個 cost accumulator，右邊這張表列了幾個時間點。20 年累積花大約 11 萬 4 千美元，30 年大約 16 萬 2 千，50 年大約 24 萬 7 千 —— 大致上是線性成長。</a:t>
+            </a:r>
+          </a:p>
+          <a:p/>
+          <a:p>
+            <a:r>
+              <a:t>那重點是 cost-effectiveness 隨時間「明顯變好」。每避免一個感染的成本：20 年的時候是 372 美元，30 年降到 102 美元，50 年只剩 18 美元。原因是早期 baseline 疫情還沒起來，能避免的感染很少，所以看起來貴；等到 baseline 加速衝向每年 791 的高峰，而疫苗這邊一直接近零，avoided infections 增加得比成本快很多，單價就一路往下掉。</a:t>
+            </a:r>
+          </a:p>
+          <a:p/>
+          <a:p>
+            <a:r>
+              <a:t>30 年的 102 美元，落在 Stover 跟 Garnett 2002 報告的範圍內，算合理。另外飽和之後，疫苗會因為保護力衰退、加上新人長大，持續以大約每年 407 劑、約 4070 美元的速率 re-vaccinate。我要強調一下，因為這是一個很小的合成人口，能搬到別處用的指標是「每避免一個感染的成本」，而不是總金額。</a:t>
             </a:r>
           </a:p>
         </p:txBody>
@@ -4793,7 +5551,7 @@
           <p:nvPr/>
         </p:nvPicPr>
         <p:blipFill>
-          <a:blip r:embed="rId2"/>
+          <a:blip r:embed="rId3"/>
           <a:stretch>
             <a:fillRect/>
           </a:stretch>
@@ -5390,7 +6148,7 @@
           <p:nvPr/>
         </p:nvPicPr>
         <p:blipFill>
-          <a:blip r:embed="rId2"/>
+          <a:blip r:embed="rId3"/>
           <a:stretch>
             <a:fillRect/>
           </a:stretch>
@@ -6022,7 +6780,7 @@
           <p:nvPr/>
         </p:nvPicPr>
         <p:blipFill>
-          <a:blip r:embed="rId2"/>
+          <a:blip r:embed="rId3"/>
           <a:stretch>
             <a:fillRect/>
           </a:stretch>
@@ -12018,7 +12776,7 @@
           <p:nvPr/>
         </p:nvPicPr>
         <p:blipFill>
-          <a:blip r:embed="rId2"/>
+          <a:blip r:embed="rId3"/>
           <a:stretch>
             <a:fillRect/>
           </a:stretch>
@@ -12732,7 +13490,7 @@
           <p:nvPr/>
         </p:nvPicPr>
         <p:blipFill>
-          <a:blip r:embed="rId2"/>
+          <a:blip r:embed="rId3"/>
           <a:stretch>
             <a:fillRect/>
           </a:stretch>
@@ -13392,7 +14150,7 @@
           <p:nvPr/>
         </p:nvPicPr>
         <p:blipFill>
-          <a:blip r:embed="rId2"/>
+          <a:blip r:embed="rId3"/>
           <a:stretch>
             <a:fillRect/>
           </a:stretch>
@@ -14134,7 +14892,7 @@
           <p:nvPr/>
         </p:nvPicPr>
         <p:blipFill>
-          <a:blip r:embed="rId2"/>
+          <a:blip r:embed="rId3"/>
           <a:stretch>
             <a:fillRect/>
           </a:stretch>
@@ -14812,7 +15570,7 @@
           <p:nvPr/>
         </p:nvPicPr>
         <p:blipFill>
-          <a:blip r:embed="rId2"/>
+          <a:blip r:embed="rId3"/>
           <a:stretch>
             <a:fillRect/>
           </a:stretch>

</xml_diff>